<commit_message>
Pitch deck: remove overclaims (confirmed burns, verified income, certificate)
Edit the committed PPTX text in place and the deck generator strings:
strict-tier burn candidates instead of "confirmed burns", no claim of
verified farmer income, and a prototype no-burn certificate with a QR
metadata check. The PDF export and embedded figures need a full rebuild.

Co-Authored-By: Claude Opus 5.5 <noreply@anthropic.com>
Claude-Session: https://claude.ai/code/session_01DXR7Kp4MVKqitcLzKSNAPu
</commit_message>
<xml_diff>
--- a/reports/pitch/Parali_Se_Paisa_Greenovators2026.pptx
+++ b/reports/pitch/Parali_Se_Paisa_Greenovators2026.pptx
@@ -1074,7 +1074,7 @@
           <a:lstStyle/>
           <a:p>
             <a:r>
-              <a:t>Only 8 percent of 2025's confirmed field burns had a VIIRS alert anywhere within 500 metres during the burn window, against 34 percent in 2023. Unburned control fields match 4 percent by proximity alone, so the true share is lower still. And at the peak, smoke blinds ordinary optical monitoring too, which our SWIR logic is built to survive.</a:t>
+              <a:t>Only 8 percent of 2025's strict-tier field burn candidates had a VIIRS alert anywhere within 500 metres during the burn window, against 34 percent in 2023. Unburned control fields match 4 percent by proximity alone, so the true share is lower still. And at the peak, smoke blinds ordinary optical monitoring too, which our SWIR logic is built to survive.</a:t>
             </a:r>
           </a:p>
         </p:txBody>
@@ -4558,7 +4558,7 @@
                 </a:solidFill>
                 <a:latin typeface="Segoe UI"/>
               </a:rPr>
-              <a:t>Satellite AI that turns paddy straw into verified farmer income</a:t>
+              <a:t>Satellite AI that helps turn paddy straw into farmer income</a:t>
             </a:r>
           </a:p>
           <a:p>
@@ -4946,7 +4946,7 @@
                 </a:solidFill>
                 <a:latin typeface="Segoe UI"/>
               </a:rPr>
-              <a:t>No-burn certificate with QR verification</a:t>
+              <a:t>Prototype no-burn certificate with QR metadata check</a:t>
             </a:r>
           </a:p>
         </p:txBody>
@@ -6031,7 +6031,7 @@
                 </a:solidFill>
                 <a:latin typeface="Segoe UI"/>
               </a:rPr>
-              <a:t>Fire alerts −79% · burn scars unchanged · 92% of confirmed burns unseen by fire satellites (2025)</a:t>
+              <a:t>Fire alerts −79% · burn scars unchanged · 92% of strict-tier burn candidates unseen by fire satellites (2025)</a:t>
             </a:r>
           </a:p>
           <a:p>
@@ -7625,7 +7625,7 @@
                 </a:solidFill>
                 <a:latin typeface="Segoe UI"/>
               </a:rPr>
-              <a:t>Sentinel-2 at a harmonised 5-day revisit. Strict = char-confirmed tier; loose = all burn candidates. 2024 burn area is a lower bound (smog gap, 3–21 Nov).</a:t>
+              <a:t>Sentinel-2 at a harmonised 5-day revisit. Strict = char-like signature tier; loose = all burn candidates; both are unverified rule candidates. 2024 burn area is a lower bound (smog gap, 3–21 Nov).</a:t>
             </a:r>
           </a:p>
         </p:txBody>
@@ -7761,7 +7761,7 @@
                 </a:solidFill>
                 <a:latin typeface="Segoe UI"/>
               </a:rPr>
-              <a:t>char-confirmed burn area (index 101)</a:t>
+              <a:t>strict-tier burn-scar candidate area (index 101)</a:t>
             </a:r>
           </a:p>
           <a:p>
@@ -7915,7 +7915,7 @@
                 </a:solidFill>
                 <a:latin typeface="Segoe UI"/>
               </a:rPr>
-              <a:t>9 in 10 confirmed burns in 2025 raised no fire alert</a:t>
+              <a:t>9 in 10 strict-tier burn candidates in 2025 raised no fire alert</a:t>
             </a:r>
           </a:p>
         </p:txBody>
@@ -8089,7 +8089,7 @@
                 </a:solidFill>
                 <a:latin typeface="Segoe UI"/>
               </a:rPr>
-              <a:t>confirmed burns with any VIIRS alert (control 4%)</a:t>
+              <a:t>strict-tier burn candidates with any VIIRS alert (control 4%)</a:t>
             </a:r>
           </a:p>
           <a:p>

</xml_diff>